<commit_message>
Actualización automática: 2026-10-05 17:15:46
</commit_message>
<xml_diff>
--- a/sles15-upgradeV1/docs/presentacion/ansible-sles-upgrade-presentacion-ejecutiva.pptx
+++ b/sles15-upgradeV1/docs/presentacion/ansible-sles-upgrade-presentacion-ejecutiva.pptx
@@ -19,6 +19,7 @@
     <p:sldId id="267" r:id="rId18"/>
     <p:sldId id="268" r:id="rId19"/>
     <p:sldId id="269" r:id="rId20"/>
+    <p:sldId id="270" r:id="rId21"/>
   </p:sldIdLst>
   <p:sldSz cx="12191695" cy="6858000" type="screen4x3"/>
   <p:notesSz cx="6858000" cy="9144000"/>
@@ -3273,7 +3274,7 @@
               </a:defRPr>
             </a:pPr>
             <a:r>
-              <a:t>Validación de GeoPOS antes y después</a:t>
+              <a:t>Controles y consideraciones para producción</a:t>
             </a:r>
           </a:p>
         </p:txBody>
@@ -3304,14 +3305,14 @@
               <a:spcAft>
                 <a:spcPts val="1000"/>
               </a:spcAft>
-              <a:defRPr sz="1800">
+              <a:defRPr sz="1500">
                 <a:solidFill>
                   <a:srgbClr val="333333"/>
                 </a:solidFill>
               </a:defRPr>
             </a:pPr>
             <a:r>
-              <a:t>•  GeoPOS se valida en cuatro dimensiones configurables por servidor: servicios, procesos Java, puertos y (opcionalmente) health checks.</a:t>
+              <a:t>•  Un servidor a la vez por defecto (procesamiento serial), para minimizar el impacto de cualquier imprevisto.</a:t>
             </a:r>
           </a:p>
           <a:p>
@@ -3319,14 +3320,14 @@
               <a:spcAft>
                 <a:spcPts val="1000"/>
               </a:spcAft>
-              <a:defRPr sz="1800">
+              <a:defRPr sz="1500">
                 <a:solidFill>
                   <a:srgbClr val="333333"/>
                 </a:solidFill>
               </a:defRPr>
             </a:pPr>
             <a:r>
-              <a:t>•  Cada servidor puede tener cero, uno o varios elementos en cada categoría; no se asume una configuración única para todos.</a:t>
+              <a:t>•  Ensayo real disponible (VALIDATE) antes de cualquier cambio, y una verificación interna obligatoria se repite automáticamente justo antes de aplicar cualquier cambio real.</a:t>
             </a:r>
           </a:p>
           <a:p>
@@ -3334,14 +3335,14 @@
               <a:spcAft>
                 <a:spcPts val="1000"/>
               </a:spcAft>
-              <a:defRPr sz="1800">
+              <a:defRPr sz="1500">
                 <a:solidFill>
                   <a:srgbClr val="333333"/>
                 </a:solidFill>
               </a:defRPr>
             </a:pPr>
             <a:r>
-              <a:t>•  Si un componente marcado como crítico no está saludable antes de iniciar, el upgrade de ese servidor se bloquea por política (configurable para excepciones autorizadas).</a:t>
+              <a:t>•  Una migración real requiere una confirmación explícita adicional, verificada antes de tocar cualquier repositorio; no puede ocurrir por accidente.</a:t>
             </a:r>
           </a:p>
           <a:p>
@@ -3349,14 +3350,59 @@
               <a:spcAft>
                 <a:spcPts val="1000"/>
               </a:spcAft>
-              <a:defRPr sz="1800">
+              <a:defRPr sz="1500">
                 <a:solidFill>
                   <a:srgbClr val="333333"/>
                 </a:solidFill>
               </a:defRPr>
             </a:pPr>
             <a:r>
-              <a:t>•  Después de una migración real, GeoPOS se vuelve a validar: alcanzar el Service Pack objetivo no se considera éxito si GeoPOS quedó insalubre.</a:t>
+              <a:t>•  El reinicio tras una migración real es siempre obligatorio: no existe una opción para omitirlo.</a:t>
+            </a:r>
+          </a:p>
+          <a:p>
+            <a:pPr>
+              <a:spcAft>
+                <a:spcPts val="1000"/>
+              </a:spcAft>
+              <a:defRPr sz="1500">
+                <a:solidFill>
+                  <a:srgbClr val="333333"/>
+                </a:solidFill>
+              </a:defRPr>
+            </a:pPr>
+            <a:r>
+              <a:t>•  SP6 debe quedar realmente validado (aplicado, reiniciado, sistema operativo, servicios y GeoPOS) antes de que el mismo servidor continúe hacia SP7.</a:t>
+            </a:r>
+          </a:p>
+          <a:p>
+            <a:pPr>
+              <a:spcAft>
+                <a:spcPts val="1000"/>
+              </a:spcAft>
+              <a:defRPr sz="1500">
+                <a:solidFill>
+                  <a:srgbClr val="333333"/>
+                </a:solidFill>
+              </a:defRPr>
+            </a:pPr>
+            <a:r>
+              <a:t>•  Ante cualquier fallo, la información de diagnóstico se conserva por defecto en el propio servidor (no se limpia a ciegas).</a:t>
+            </a:r>
+          </a:p>
+          <a:p>
+            <a:pPr>
+              <a:spcAft>
+                <a:spcPts val="1000"/>
+              </a:spcAft>
+              <a:defRPr sz="1500">
+                <a:solidFill>
+                  <a:srgbClr val="333333"/>
+                </a:solidFill>
+              </a:defRPr>
+            </a:pPr>
+            <a:r>
+              <a:t>•  El alcance de servidores se controla con el CRQ/Lote/Ambiente del Survey, verificados contra el inventario: si no coinciden con ningún servidor, la ejecución falla antes de tocar nada — evitando ejecuciones accidentales sobre servidores no previstos.</a:t>
             </a:r>
           </a:p>
         </p:txBody>
@@ -3495,7 +3541,7 @@
               </a:defRPr>
             </a:pPr>
             <a:r>
-              <a:t>Reportes y trazabilidad</a:t>
+              <a:t>Validación de GeoPOS antes y después</a:t>
             </a:r>
           </a:p>
         </p:txBody>
@@ -3526,14 +3572,14 @@
               <a:spcAft>
                 <a:spcPts val="1000"/>
               </a:spcAft>
-              <a:defRPr sz="1500">
+              <a:defRPr sz="1800">
                 <a:solidFill>
                   <a:srgbClr val="333333"/>
                 </a:solidFill>
               </a:defRPr>
             </a:pPr>
             <a:r>
-              <a:t>•  Cada servidor y cada etapa generan un reporte legible (HTML) con el resultado y el detalle de cada verificación.</a:t>
+              <a:t>•  GeoPOS se valida en cuatro dimensiones configurables por servidor: servicios, procesos Java, puertos y (opcionalmente) health checks.</a:t>
             </a:r>
           </a:p>
           <a:p>
@@ -3541,14 +3587,14 @@
               <a:spcAft>
                 <a:spcPts val="1000"/>
               </a:spcAft>
-              <a:defRPr sz="1500">
+              <a:defRPr sz="1800">
                 <a:solidFill>
                   <a:srgbClr val="333333"/>
                 </a:solidFill>
               </a:defRPr>
             </a:pPr>
             <a:r>
-              <a:t>•  Estados claros: OK, ADVERTENCIA, FALLIDO, NO VERIFICADO — sin ambigüedad sobre lo que realmente se comprobó.</a:t>
+              <a:t>•  Cada servidor puede tener cero, uno o varios elementos en cada categoría; no se asume una configuración única para todos.</a:t>
             </a:r>
           </a:p>
           <a:p>
@@ -3556,14 +3602,14 @@
               <a:spcAft>
                 <a:spcPts val="1000"/>
               </a:spcAft>
-              <a:defRPr sz="1500">
+              <a:defRPr sz="1800">
                 <a:solidFill>
                   <a:srgbClr val="333333"/>
                 </a:solidFill>
               </a:defRPr>
             </a:pPr>
             <a:r>
-              <a:t>•  Un resumen consolidado permite ver, de un vistazo, el estado de todos los servidores procesados.</a:t>
+              <a:t>•  Si un componente marcado como crítico no está saludable antes de iniciar, el upgrade de ese servidor se bloquea por política (configurable para excepciones autorizadas).</a:t>
             </a:r>
           </a:p>
           <a:p>
@@ -3571,29 +3617,14 @@
               <a:spcAft>
                 <a:spcPts val="1000"/>
               </a:spcAft>
-              <a:defRPr sz="1500">
+              <a:defRPr sz="1800">
                 <a:solidFill>
                   <a:srgbClr val="333333"/>
                 </a:solidFill>
               </a:defRPr>
             </a:pPr>
             <a:r>
-              <a:t>•  El operador puede determinar si la migración fue satisfactoria sin conectarse por SSH ni revisar todo el log del Job en AWX.</a:t>
-            </a:r>
-          </a:p>
-          <a:p>
-            <a:pPr>
-              <a:spcAft>
-                <a:spcPts val="1000"/>
-              </a:spcAft>
-              <a:defRPr sz="1500">
-                <a:solidFill>
-                  <a:srgbClr val="333333"/>
-                </a:solidFill>
-              </a:defRPr>
-            </a:pPr>
-            <a:r>
-              <a:t>•  Importante: para que los reportes se conserven más allá de cada ejecución, se necesita definir un destino de almacenamiento persistente real; mientras no exista, solo están garantizados durante esa ejecución puntual.</a:t>
+              <a:t>•  Después de una migración real, GeoPOS se vuelve a validar: alcanzar el Service Pack objetivo no se considera éxito si GeoPOS quedó insalubre.</a:t>
             </a:r>
           </a:p>
         </p:txBody>
@@ -3732,7 +3763,7 @@
               </a:defRPr>
             </a:pPr>
             <a:r>
-              <a:t>Riesgos principales y próximos pasos</a:t>
+              <a:t>Reportes y trazabilidad</a:t>
             </a:r>
           </a:p>
         </p:txBody>
@@ -3745,8 +3776,8 @@
         </p:nvSpPr>
         <p:spPr>
           <a:xfrm>
-            <a:off x="548640" y="1371600"/>
-            <a:ext cx="5486400" cy="4846320"/>
+            <a:off x="640080" y="1371600"/>
+            <a:ext cx="10911535" cy="4846320"/>
           </a:xfrm>
           <a:prstGeom prst="rect">
             <a:avLst/>
@@ -3760,74 +3791,77 @@
           <a:lstStyle/>
           <a:p>
             <a:pPr>
-              <a:defRPr sz="1800" b="1">
-                <a:solidFill>
-                  <a:srgbClr val="1B2A4A"/>
-                </a:solidFill>
-              </a:defRPr>
-            </a:pPr>
-            <a:r>
-              <a:t>Riesgos y cómo se controlan</a:t>
-            </a:r>
-          </a:p>
-          <a:p>
-            <a:pPr>
-              <a:spcBef>
-                <a:spcPts val="800"/>
-              </a:spcBef>
-              <a:defRPr sz="1400">
+              <a:spcAft>
+                <a:spcPts val="1000"/>
+              </a:spcAft>
+              <a:defRPr sz="1500">
                 <a:solidFill>
                   <a:srgbClr val="333333"/>
                 </a:solidFill>
               </a:defRPr>
             </a:pPr>
             <a:r>
-              <a:t>•  Interrupción del servicio durante el upgrade → ensayo real previo (VALIDATE), un servidor a la vez, validación GeoPOS antes/después.</a:t>
-            </a:r>
-          </a:p>
-          <a:p>
-            <a:pPr>
-              <a:spcBef>
-                <a:spcPts val="800"/>
-              </a:spcBef>
-              <a:defRPr sz="1400">
+              <a:t>•  Cada servidor y cada etapa generan un reporte legible (HTML) con el resultado y el detalle de cada verificación.</a:t>
+            </a:r>
+          </a:p>
+          <a:p>
+            <a:pPr>
+              <a:spcAft>
+                <a:spcPts val="1000"/>
+              </a:spcAft>
+              <a:defRPr sz="1500">
                 <a:solidFill>
                   <a:srgbClr val="333333"/>
                 </a:solidFill>
               </a:defRPr>
             </a:pPr>
             <a:r>
-              <a:t>•  Repositorios incorrectos o inaccesibles → verificación de conectividad antes de modificar el sistema; nunca se inventan datos de Foreman.</a:t>
-            </a:r>
-          </a:p>
-          <a:p>
-            <a:pPr>
-              <a:spcBef>
-                <a:spcPts val="800"/>
-              </a:spcBef>
-              <a:defRPr sz="1400">
+              <a:t>•  Estados claros: OK, ADVERTENCIA, FALLIDO, NO VERIFICADO — sin ambigüedad sobre lo que realmente se comprobó.</a:t>
+            </a:r>
+          </a:p>
+          <a:p>
+            <a:pPr>
+              <a:spcAft>
+                <a:spcPts val="1000"/>
+              </a:spcAft>
+              <a:defRPr sz="1500">
                 <a:solidFill>
                   <a:srgbClr val="333333"/>
                 </a:solidFill>
               </a:defRPr>
             </a:pPr>
             <a:r>
-              <a:t>•  Falta de evidencia de rollback real → el proyecto no afirma capacidad de rollback automático salvo que el servidor use Btrfs con snapshots.</a:t>
-            </a:r>
-          </a:p>
-          <a:p>
-            <a:pPr>
-              <a:spcBef>
-                <a:spcPts val="800"/>
-              </a:spcBef>
-              <a:defRPr sz="1400">
+              <a:t>•  Un resumen consolidado permite ver, de un vistazo, el estado de todos los servidores procesados.</a:t>
+            </a:r>
+          </a:p>
+          <a:p>
+            <a:pPr>
+              <a:spcAft>
+                <a:spcPts val="1000"/>
+              </a:spcAft>
+              <a:defRPr sz="1500">
                 <a:solidFill>
                   <a:srgbClr val="333333"/>
                 </a:solidFill>
               </a:defRPr>
             </a:pPr>
             <a:r>
-              <a:t>•  Ejecución accidental contra servidores no previstos → el alcance siempre se define explícitamente desde AWX.</a:t>
+              <a:t>•  El operador puede determinar si la migración fue satisfactoria sin conectarse por SSH ni revisar todo el log del Job en AWX.</a:t>
+            </a:r>
+          </a:p>
+          <a:p>
+            <a:pPr>
+              <a:spcAft>
+                <a:spcPts val="1000"/>
+              </a:spcAft>
+              <a:defRPr sz="1500">
+                <a:solidFill>
+                  <a:srgbClr val="333333"/>
+                </a:solidFill>
+              </a:defRPr>
+            </a:pPr>
+            <a:r>
+              <a:t>•  Importante: para que los reportes se conserven más allá de cada ejecución, se necesita definir un destino de almacenamiento persistente real; mientras no exista, solo están garantizados durante esa ejecución puntual.</a:t>
             </a:r>
           </a:p>
         </p:txBody>
@@ -3835,101 +3869,6 @@
       <p:sp>
         <p:nvSpPr>
           <p:cNvPr id="5" name="TextBox 4"/>
-          <p:cNvSpPr txBox="1"/>
-          <p:nvPr/>
-        </p:nvSpPr>
-        <p:spPr>
-          <a:xfrm>
-            <a:off x="6400800" y="1371600"/>
-            <a:ext cx="5212080" cy="4846320"/>
-          </a:xfrm>
-          <a:prstGeom prst="rect">
-            <a:avLst/>
-          </a:prstGeom>
-          <a:noFill/>
-        </p:spPr>
-        <p:txBody>
-          <a:bodyPr wrap="square">
-            <a:spAutoFit/>
-          </a:bodyPr>
-          <a:lstStyle/>
-          <a:p>
-            <a:pPr>
-              <a:defRPr sz="1800" b="1">
-                <a:solidFill>
-                  <a:srgbClr val="1B2A4A"/>
-                </a:solidFill>
-              </a:defRPr>
-            </a:pPr>
-            <a:r>
-              <a:t>Próximos pasos</a:t>
-            </a:r>
-          </a:p>
-          <a:p>
-            <a:pPr>
-              <a:spcBef>
-                <a:spcPts val="800"/>
-              </a:spcBef>
-              <a:defRPr sz="1400">
-                <a:solidFill>
-                  <a:srgbClr val="333333"/>
-                </a:solidFill>
-              </a:defRPr>
-            </a:pPr>
-            <a:r>
-              <a:t>•  Repositorios Foreman/Katello y CA interna: ya completados, verificados e instalación automatizada (SP4 a SP7). Pendiente real: servicios/puertos de GeoPOS, destino definitivo de los reportes.</a:t>
-            </a:r>
-          </a:p>
-          <a:p>
-            <a:pPr>
-              <a:spcBef>
-                <a:spcPts val="800"/>
-              </a:spcBef>
-              <a:defRPr sz="1400">
-                <a:solidFill>
-                  <a:srgbClr val="333333"/>
-                </a:solidFill>
-              </a:defRPr>
-            </a:pPr>
-            <a:r>
-              <a:t>•  Configurar los objetos de AWX (Inventory, Credential, Job Template, Survey) con datos del ambiente.</a:t>
-            </a:r>
-          </a:p>
-          <a:p>
-            <a:pPr>
-              <a:spcBef>
-                <a:spcPts val="800"/>
-              </a:spcBef>
-              <a:defRPr sz="1400">
-                <a:solidFill>
-                  <a:srgbClr val="333333"/>
-                </a:solidFill>
-              </a:defRPr>
-            </a:pPr>
-            <a:r>
-              <a:t>•  Ejecutar precheck y luego validate en un servidor de laboratorio antes de la primera ejecución real.</a:t>
-            </a:r>
-          </a:p>
-          <a:p>
-            <a:pPr>
-              <a:spcBef>
-                <a:spcPts val="800"/>
-              </a:spcBef>
-              <a:defRPr sz="1400">
-                <a:solidFill>
-                  <a:srgbClr val="333333"/>
-                </a:solidFill>
-              </a:defRPr>
-            </a:pPr>
-            <a:r>
-              <a:t>•  Definir la ventana de mantenimiento y acordar el criterio de éxito con el equipo de GeoPOS.</a:t>
-            </a:r>
-          </a:p>
-        </p:txBody>
-      </p:sp>
-      <p:sp>
-        <p:nvSpPr>
-          <p:cNvPr id="6" name="TextBox 5"/>
           <p:cNvSpPr txBox="1"/>
           <p:nvPr/>
         </p:nvSpPr>
@@ -4061,19 +4000,7 @@
               </a:defRPr>
             </a:pPr>
             <a:r>
-              <a:t>Anexo: arquitectura técnica</a:t>
-            </a:r>
-          </a:p>
-          <a:p>
-            <a:pPr>
-              <a:defRPr sz="1400">
-                <a:solidFill>
-                  <a:srgbClr val="C9D6E8"/>
-                </a:solidFill>
-              </a:defRPr>
-            </a:pPr>
-            <a:r>
-              <a:t>Diapositiva opcional para audiencia técnica</a:t>
+              <a:t>Riesgos principales y próximos pasos</a:t>
             </a:r>
           </a:p>
         </p:txBody>
@@ -4086,8 +4013,8 @@
         </p:nvSpPr>
         <p:spPr>
           <a:xfrm>
-            <a:off x="640080" y="1371600"/>
-            <a:ext cx="10911535" cy="4846320"/>
+            <a:off x="548640" y="1371600"/>
+            <a:ext cx="5486400" cy="4846320"/>
           </a:xfrm>
           <a:prstGeom prst="rect">
             <a:avLst/>
@@ -4101,62 +4028,74 @@
           <a:lstStyle/>
           <a:p>
             <a:pPr>
-              <a:spcAft>
-                <a:spcPts val="1000"/>
-              </a:spcAft>
-              <a:defRPr sz="1600">
+              <a:defRPr sz="1800" b="1">
+                <a:solidFill>
+                  <a:srgbClr val="1B2A4A"/>
+                </a:solidFill>
+              </a:defRPr>
+            </a:pPr>
+            <a:r>
+              <a:t>Riesgos y cómo se controlan</a:t>
+            </a:r>
+          </a:p>
+          <a:p>
+            <a:pPr>
+              <a:spcBef>
+                <a:spcPts val="800"/>
+              </a:spcBef>
+              <a:defRPr sz="1400">
                 <a:solidFill>
                   <a:srgbClr val="333333"/>
                 </a:solidFill>
               </a:defRPr>
             </a:pPr>
             <a:r>
-              <a:t>•  Un solo playbook de entrada, controlado por el modo de ejecución (precheck / validate / sp4_to_sp5 / sp5_to_sp6 / sp6_to_sp7 / full).</a:t>
-            </a:r>
-          </a:p>
-          <a:p>
-            <a:pPr>
-              <a:spcAft>
-                <a:spcPts val="1000"/>
-              </a:spcAft>
-              <a:defRPr sz="1600">
+              <a:t>•  Interrupción del servicio durante el upgrade → ensayo real previo (VALIDATE), un servidor a la vez, validación GeoPOS antes/después.</a:t>
+            </a:r>
+          </a:p>
+          <a:p>
+            <a:pPr>
+              <a:spcBef>
+                <a:spcPts val="800"/>
+              </a:spcBef>
+              <a:defRPr sz="1400">
                 <a:solidFill>
                   <a:srgbClr val="333333"/>
                 </a:solidFill>
               </a:defRPr>
             </a:pPr>
             <a:r>
-              <a:t>•  Un solo rol de migración parametrizado, reutilizado para las tres etapas — la diferencia entre ellas es de datos (repositorios, opción --releasever), no de procedimiento.</a:t>
-            </a:r>
-          </a:p>
-          <a:p>
-            <a:pPr>
-              <a:spcAft>
-                <a:spcPts val="1000"/>
-              </a:spcAft>
-              <a:defRPr sz="1600">
+              <a:t>•  Repositorios incorrectos o inaccesibles → verificación de conectividad antes de modificar el sistema; nunca se inventan datos de Foreman.</a:t>
+            </a:r>
+          </a:p>
+          <a:p>
+            <a:pPr>
+              <a:spcBef>
+                <a:spcPts val="800"/>
+              </a:spcBef>
+              <a:defRPr sz="1400">
                 <a:solidFill>
                   <a:srgbClr val="333333"/>
                 </a:solidFill>
               </a:defRPr>
             </a:pPr>
             <a:r>
-              <a:t>•  El ensayo real (VALIDATE) usa un directorio de repositorios temporal y aislado que Zypper consulta en lugar del real, y que se elimina siempre al finalizar.</a:t>
-            </a:r>
-          </a:p>
-          <a:p>
-            <a:pPr>
-              <a:spcAft>
-                <a:spcPts val="1000"/>
-              </a:spcAft>
-              <a:defRPr sz="1600">
+              <a:t>•  Falta de evidencia de rollback real → el proyecto no afirma capacidad de rollback automático salvo que el servidor use Btrfs con snapshots.</a:t>
+            </a:r>
+          </a:p>
+          <a:p>
+            <a:pPr>
+              <a:spcBef>
+                <a:spcPts val="800"/>
+              </a:spcBef>
+              <a:defRPr sz="1400">
                 <a:solidFill>
                   <a:srgbClr val="333333"/>
                 </a:solidFill>
               </a:defRPr>
             </a:pPr>
             <a:r>
-              <a:t>•  El diseño técnico completo, con sus justificaciones, está documentado en docs/ARQUITECTURA_Y_DISENO_TECNICO.html del propio repositorio.</a:t>
+              <a:t>•  Ejecución accidental contra servidores no previstos → el alcance siempre se define explícitamente desde AWX.</a:t>
             </a:r>
           </a:p>
         </p:txBody>
@@ -4164,6 +4103,101 @@
       <p:sp>
         <p:nvSpPr>
           <p:cNvPr id="5" name="TextBox 4"/>
+          <p:cNvSpPr txBox="1"/>
+          <p:nvPr/>
+        </p:nvSpPr>
+        <p:spPr>
+          <a:xfrm>
+            <a:off x="6400800" y="1371600"/>
+            <a:ext cx="5212080" cy="4846320"/>
+          </a:xfrm>
+          <a:prstGeom prst="rect">
+            <a:avLst/>
+          </a:prstGeom>
+          <a:noFill/>
+        </p:spPr>
+        <p:txBody>
+          <a:bodyPr wrap="square">
+            <a:spAutoFit/>
+          </a:bodyPr>
+          <a:lstStyle/>
+          <a:p>
+            <a:pPr>
+              <a:defRPr sz="1800" b="1">
+                <a:solidFill>
+                  <a:srgbClr val="1B2A4A"/>
+                </a:solidFill>
+              </a:defRPr>
+            </a:pPr>
+            <a:r>
+              <a:t>Próximos pasos</a:t>
+            </a:r>
+          </a:p>
+          <a:p>
+            <a:pPr>
+              <a:spcBef>
+                <a:spcPts val="800"/>
+              </a:spcBef>
+              <a:defRPr sz="1400">
+                <a:solidFill>
+                  <a:srgbClr val="333333"/>
+                </a:solidFill>
+              </a:defRPr>
+            </a:pPr>
+            <a:r>
+              <a:t>•  Repositorios Foreman/Katello y CA interna: ya completados, verificados e instalación automatizada (SP4 a SP7). Pendiente real: servicios/puertos de GeoPOS, destino definitivo de los reportes.</a:t>
+            </a:r>
+          </a:p>
+          <a:p>
+            <a:pPr>
+              <a:spcBef>
+                <a:spcPts val="800"/>
+              </a:spcBef>
+              <a:defRPr sz="1400">
+                <a:solidFill>
+                  <a:srgbClr val="333333"/>
+                </a:solidFill>
+              </a:defRPr>
+            </a:pPr>
+            <a:r>
+              <a:t>•  Configurar los objetos de AWX (Inventory, Credential, Job Template, Survey) con datos del ambiente.</a:t>
+            </a:r>
+          </a:p>
+          <a:p>
+            <a:pPr>
+              <a:spcBef>
+                <a:spcPts val="800"/>
+              </a:spcBef>
+              <a:defRPr sz="1400">
+                <a:solidFill>
+                  <a:srgbClr val="333333"/>
+                </a:solidFill>
+              </a:defRPr>
+            </a:pPr>
+            <a:r>
+              <a:t>•  Ejecutar precheck y luego validate en un servidor de laboratorio antes de la primera ejecución real.</a:t>
+            </a:r>
+          </a:p>
+          <a:p>
+            <a:pPr>
+              <a:spcBef>
+                <a:spcPts val="800"/>
+              </a:spcBef>
+              <a:defRPr sz="1400">
+                <a:solidFill>
+                  <a:srgbClr val="333333"/>
+                </a:solidFill>
+              </a:defRPr>
+            </a:pPr>
+            <a:r>
+              <a:t>•  Definir la ventana de mantenimiento y acordar el criterio de éxito con el equipo de GeoPOS.</a:t>
+            </a:r>
+          </a:p>
+        </p:txBody>
+      </p:sp>
+      <p:sp>
+        <p:nvSpPr>
+          <p:cNvPr id="6" name="TextBox 5"/>
           <p:cNvSpPr txBox="1"/>
           <p:nvPr/>
         </p:nvSpPr>
@@ -4191,7 +4225,7 @@
               </a:defRPr>
             </a:pPr>
             <a:r>
-              <a:t>ansible-sles-upgrade · Anexo técnico</a:t>
+              <a:t>ansible-sles-upgrade · Presentación ejecutiva</a:t>
             </a:r>
           </a:p>
         </p:txBody>
@@ -4295,6 +4329,240 @@
               </a:defRPr>
             </a:pPr>
             <a:r>
+              <a:t>Anexo: arquitectura técnica</a:t>
+            </a:r>
+          </a:p>
+          <a:p>
+            <a:pPr>
+              <a:defRPr sz="1400">
+                <a:solidFill>
+                  <a:srgbClr val="C9D6E8"/>
+                </a:solidFill>
+              </a:defRPr>
+            </a:pPr>
+            <a:r>
+              <a:t>Diapositiva opcional para audiencia técnica</a:t>
+            </a:r>
+          </a:p>
+        </p:txBody>
+      </p:sp>
+      <p:sp>
+        <p:nvSpPr>
+          <p:cNvPr id="4" name="TextBox 3"/>
+          <p:cNvSpPr txBox="1"/>
+          <p:nvPr/>
+        </p:nvSpPr>
+        <p:spPr>
+          <a:xfrm>
+            <a:off x="640080" y="1371600"/>
+            <a:ext cx="10911535" cy="4846320"/>
+          </a:xfrm>
+          <a:prstGeom prst="rect">
+            <a:avLst/>
+          </a:prstGeom>
+          <a:noFill/>
+        </p:spPr>
+        <p:txBody>
+          <a:bodyPr wrap="square">
+            <a:spAutoFit/>
+          </a:bodyPr>
+          <a:lstStyle/>
+          <a:p>
+            <a:pPr>
+              <a:spcAft>
+                <a:spcPts val="1000"/>
+              </a:spcAft>
+              <a:defRPr sz="1600">
+                <a:solidFill>
+                  <a:srgbClr val="333333"/>
+                </a:solidFill>
+              </a:defRPr>
+            </a:pPr>
+            <a:r>
+              <a:t>•  Un solo playbook de entrada, controlado por el modo de ejecución (precheck / validate / sp4_to_sp5 / sp5_to_sp6 / sp6_to_sp7 / full).</a:t>
+            </a:r>
+          </a:p>
+          <a:p>
+            <a:pPr>
+              <a:spcAft>
+                <a:spcPts val="1000"/>
+              </a:spcAft>
+              <a:defRPr sz="1600">
+                <a:solidFill>
+                  <a:srgbClr val="333333"/>
+                </a:solidFill>
+              </a:defRPr>
+            </a:pPr>
+            <a:r>
+              <a:t>•  Un solo rol de migración parametrizado, reutilizado para las tres etapas — la diferencia entre ellas es de datos (repositorios, opción --releasever), no de procedimiento.</a:t>
+            </a:r>
+          </a:p>
+          <a:p>
+            <a:pPr>
+              <a:spcAft>
+                <a:spcPts val="1000"/>
+              </a:spcAft>
+              <a:defRPr sz="1600">
+                <a:solidFill>
+                  <a:srgbClr val="333333"/>
+                </a:solidFill>
+              </a:defRPr>
+            </a:pPr>
+            <a:r>
+              <a:t>•  El ensayo real (VALIDATE) usa un directorio de repositorios temporal y aislado que Zypper consulta en lugar del real, y que se elimina siempre al finalizar.</a:t>
+            </a:r>
+          </a:p>
+          <a:p>
+            <a:pPr>
+              <a:spcAft>
+                <a:spcPts val="1000"/>
+              </a:spcAft>
+              <a:defRPr sz="1600">
+                <a:solidFill>
+                  <a:srgbClr val="333333"/>
+                </a:solidFill>
+              </a:defRPr>
+            </a:pPr>
+            <a:r>
+              <a:t>•  El diseño técnico completo, con sus justificaciones, está documentado en docs/ARQUITECTURA_Y_DISENO_TECNICO.html del propio repositorio.</a:t>
+            </a:r>
+          </a:p>
+        </p:txBody>
+      </p:sp>
+      <p:sp>
+        <p:nvSpPr>
+          <p:cNvPr id="5" name="TextBox 4"/>
+          <p:cNvSpPr txBox="1"/>
+          <p:nvPr/>
+        </p:nvSpPr>
+        <p:spPr>
+          <a:xfrm>
+            <a:off x="457200" y="6446520"/>
+            <a:ext cx="11277295" cy="320040"/>
+          </a:xfrm>
+          <a:prstGeom prst="rect">
+            <a:avLst/>
+          </a:prstGeom>
+          <a:noFill/>
+        </p:spPr>
+        <p:txBody>
+          <a:bodyPr wrap="none">
+            <a:spAutoFit/>
+          </a:bodyPr>
+          <a:lstStyle/>
+          <a:p>
+            <a:pPr>
+              <a:defRPr sz="1100">
+                <a:solidFill>
+                  <a:srgbClr val="666666"/>
+                </a:solidFill>
+              </a:defRPr>
+            </a:pPr>
+            <a:r>
+              <a:t>ansible-sles-upgrade · Anexo técnico</a:t>
+            </a:r>
+          </a:p>
+        </p:txBody>
+      </p:sp>
+    </p:spTree>
+  </p:cSld>
+  <p:clrMapOvr>
+    <a:masterClrMapping/>
+  </p:clrMapOvr>
+</p:sld>
+</file>
+
+<file path=ppt/slides/slide15.xml><?xml version="1.0" encoding="utf-8"?>
+<p:sld xmlns:a="http://schemas.openxmlformats.org/drawingml/2006/main" xmlns:p="http://schemas.openxmlformats.org/presentationml/2006/main" xmlns:r="http://schemas.openxmlformats.org/officeDocument/2006/relationships">
+  <p:cSld>
+    <p:bg>
+      <p:bgPr>
+        <a:solidFill>
+          <a:srgbClr val="FFFFFF"/>
+        </a:solidFill>
+        <a:effectLst/>
+      </p:bgPr>
+    </p:bg>
+    <p:spTree>
+      <p:nvGrpSpPr>
+        <p:cNvPr id="1" name=""/>
+        <p:cNvGrpSpPr/>
+        <p:nvPr/>
+      </p:nvGrpSpPr>
+      <p:grpSpPr/>
+      <p:sp>
+        <p:nvSpPr>
+          <p:cNvPr id="2" name="Rectangle 1"/>
+          <p:cNvSpPr/>
+          <p:nvPr/>
+        </p:nvSpPr>
+        <p:spPr>
+          <a:xfrm>
+            <a:off x="0" y="0"/>
+            <a:ext cx="12191695" cy="1051560"/>
+          </a:xfrm>
+          <a:prstGeom prst="rect">
+            <a:avLst/>
+          </a:prstGeom>
+          <a:solidFill>
+            <a:srgbClr val="1B2A4A"/>
+          </a:solidFill>
+          <a:ln>
+            <a:noFill/>
+          </a:ln>
+        </p:spPr>
+        <p:style>
+          <a:lnRef idx="1">
+            <a:schemeClr val="accent1"/>
+          </a:lnRef>
+          <a:fillRef idx="3">
+            <a:schemeClr val="accent1"/>
+          </a:fillRef>
+          <a:effectRef idx="2">
+            <a:schemeClr val="accent1"/>
+          </a:effectRef>
+          <a:fontRef idx="minor">
+            <a:schemeClr val="lt1"/>
+          </a:fontRef>
+        </p:style>
+        <p:txBody>
+          <a:bodyPr rtlCol="0" anchor="ctr"/>
+          <a:lstStyle/>
+          <a:p>
+            <a:pPr algn="ctr"/>
+          </a:p>
+        </p:txBody>
+      </p:sp>
+      <p:sp>
+        <p:nvSpPr>
+          <p:cNvPr id="3" name="TextBox 2"/>
+          <p:cNvSpPr txBox="1"/>
+          <p:nvPr/>
+        </p:nvSpPr>
+        <p:spPr>
+          <a:xfrm>
+            <a:off x="548640" y="137160"/>
+            <a:ext cx="11094415" cy="640080"/>
+          </a:xfrm>
+          <a:prstGeom prst="rect">
+            <a:avLst/>
+          </a:prstGeom>
+          <a:noFill/>
+        </p:spPr>
+        <p:txBody>
+          <a:bodyPr wrap="square">
+            <a:spAutoFit/>
+          </a:bodyPr>
+          <a:lstStyle/>
+          <a:p>
+            <a:pPr>
+              <a:defRPr sz="2800" b="1">
+                <a:solidFill>
+                  <a:srgbClr val="FFFFFF"/>
+                </a:solidFill>
+              </a:defRPr>
+            </a:pPr>
+            <a:r>
               <a:t>Anexo: ciclo de vida de repositorios</a:t>
             </a:r>
           </a:p>
@@ -4754,7 +5022,7 @@
               </a:defRPr>
             </a:pPr>
             <a:r>
-              <a:t>5. Agregar repos Foreman de destino -&gt; migrar</a:t>
+              <a:t>5. Agregar repos Foreman de destino (listos para migrar)</a:t>
             </a:r>
           </a:p>
         </p:txBody>
@@ -4852,7 +5120,7 @@
               </a:defRPr>
             </a:pPr>
             <a:r>
-              <a:t>6. Etapa exitosa: retirar los repos Foreman de destino</a:t>
+              <a:t>6. Migrar (dup); si la etapa fue exitosa, retirar los repos Foreman de destino</a:t>
             </a:r>
           </a:p>
         </p:txBody>
@@ -4914,6 +5182,19 @@
             </a:pPr>
             <a:r>
               <a:t>Ante un fallo, todo se conserva tal cual para diagnóstico.</a:t>
+            </a:r>
+          </a:p>
+          <a:p>
+            <a:br/>
+            <a:pPr>
+              <a:defRPr sz="1300">
+                <a:solidFill>
+                  <a:srgbClr val="666666"/>
+                </a:solidFill>
+              </a:defRPr>
+            </a:pPr>
+            <a:r>
+              <a:t>Los pasos 1-5 son la etapa “Preparar”; el paso 6 (migrar + retirar destino) es la etapa “Aplicar” — ver diapositiva 6.</a:t>
             </a:r>
           </a:p>
         </p:txBody>
@@ -5570,7 +5851,7 @@
             </a:r>
             <a:br/>
             <a:r>
-              <a:t>(orquestación, Survey, Limit)</a:t>
+              <a:t>(orquestación, Survey)</a:t>
             </a:r>
           </a:p>
         </p:txBody>
@@ -5914,7 +6195,7 @@
               </a:defRPr>
             </a:pPr>
             <a:r>
-              <a:t>•  AWX dispara la ejecución (Job Template + Survey) y define el alcance de servidores con “Limit”.</a:t>
+              <a:t>•  AWX dispara la ejecución (Job Template + Survey); el alcance de servidores se define con el CRQ/Lote/Ambiente declarados en el Survey, verificados contra el inventario — nunca con un campo de selección manual aparte.</a:t>
             </a:r>
           </a:p>
           <a:p>
@@ -6790,6 +7071,19 @@
               <a:t>Una migración real requiere una confirmación explícita adicional (no ocurre por defecto), verificada antes de tocar cualquier repositorio.</a:t>
             </a:r>
           </a:p>
+          <a:p>
+            <a:br/>
+            <a:pPr>
+              <a:defRPr sz="1400">
+                <a:solidFill>
+                  <a:srgbClr val="666666"/>
+                </a:solidFill>
+              </a:defRPr>
+            </a:pPr>
+            <a:r>
+              <a:t>Los pasos 3 (preparar repos) y 4-6 (aplicar el cambio) pueden ejecutarse juntos (por defecto) o como 2 etapas separadas con aprobación entre ambas — ver diapositiva siguiente.</a:t>
+            </a:r>
+          </a:p>
         </p:txBody>
       </p:sp>
       <p:sp>
@@ -6926,7 +7220,19 @@
               </a:defRPr>
             </a:pPr>
             <a:r>
-              <a:t>Tres niveles, nunca confundidos</a:t>
+              <a:t>Opcional: separar “Preparar” de “Aplicar”</a:t>
+            </a:r>
+          </a:p>
+          <a:p>
+            <a:pPr>
+              <a:defRPr sz="1400">
+                <a:solidFill>
+                  <a:srgbClr val="C9D6E8"/>
+                </a:solidFill>
+              </a:defRPr>
+            </a:pPr>
+            <a:r>
+              <a:t>Mismo procedimiento, con un punto de control humano en el medio</a:t>
             </a:r>
           </a:p>
         </p:txBody>
@@ -6939,8 +7245,8 @@
         </p:nvSpPr>
         <p:spPr>
           <a:xfrm>
-            <a:off x="640080" y="1463040"/>
-            <a:ext cx="3520440" cy="1234440"/>
+            <a:off x="548640" y="1508760"/>
+            <a:ext cx="2514600" cy="1005840"/>
           </a:xfrm>
           <a:prstGeom prst="roundRect">
             <a:avLst/>
@@ -6974,33 +7280,80 @@
           <a:lstStyle/>
           <a:p>
             <a:pPr algn="ctr">
-              <a:defRPr sz="1600" b="1">
+              <a:defRPr sz="1400" b="1">
                 <a:solidFill>
                   <a:srgbClr val="FFFFFF"/>
                 </a:solidFill>
               </a:defRPr>
             </a:pPr>
             <a:r>
-              <a:t>PRECHECK</a:t>
+              <a:t>1. Precheck</a:t>
             </a:r>
             <a:br/>
             <a:br/>
             <a:r>
-              <a:t>¿Está el servidor listo?</a:t>
-            </a:r>
-          </a:p>
-        </p:txBody>
-      </p:sp>
-      <p:sp>
-        <p:nvSpPr>
-          <p:cNvPr id="5" name="Rounded Rectangle 4"/>
+              <a:t>¿Está listo</a:t>
+            </a:r>
+            <a:br/>
+            <a:r>
+              <a:t>el servidor?</a:t>
+            </a:r>
+          </a:p>
+        </p:txBody>
+      </p:sp>
+      <p:sp>
+        <p:nvSpPr>
+          <p:cNvPr id="5" name="Right Arrow 4"/>
           <p:cNvSpPr/>
           <p:nvPr/>
         </p:nvSpPr>
         <p:spPr>
           <a:xfrm>
-            <a:off x="4480560" y="1463040"/>
-            <a:ext cx="3520440" cy="1234440"/>
+            <a:off x="3063240" y="1901952"/>
+            <a:ext cx="320040" cy="219456"/>
+          </a:xfrm>
+          <a:prstGeom prst="rightArrow">
+            <a:avLst/>
+          </a:prstGeom>
+          <a:solidFill>
+            <a:srgbClr val="666666"/>
+          </a:solidFill>
+          <a:ln>
+            <a:noFill/>
+          </a:ln>
+        </p:spPr>
+        <p:style>
+          <a:lnRef idx="1">
+            <a:schemeClr val="accent1"/>
+          </a:lnRef>
+          <a:fillRef idx="3">
+            <a:schemeClr val="accent1"/>
+          </a:fillRef>
+          <a:effectRef idx="2">
+            <a:schemeClr val="accent1"/>
+          </a:effectRef>
+          <a:fontRef idx="minor">
+            <a:schemeClr val="lt1"/>
+          </a:fontRef>
+        </p:style>
+        <p:txBody>
+          <a:bodyPr rtlCol="0" anchor="ctr"/>
+          <a:lstStyle/>
+          <a:p>
+            <a:pPr algn="ctr"/>
+          </a:p>
+        </p:txBody>
+      </p:sp>
+      <p:sp>
+        <p:nvSpPr>
+          <p:cNvPr id="6" name="Rounded Rectangle 5"/>
+          <p:cNvSpPr/>
+          <p:nvPr/>
+        </p:nvSpPr>
+        <p:spPr>
+          <a:xfrm>
+            <a:off x="3383280" y="1508760"/>
+            <a:ext cx="2514600" cy="1005840"/>
           </a:xfrm>
           <a:prstGeom prst="roundRect">
             <a:avLst/>
@@ -7034,37 +7387,80 @@
           <a:lstStyle/>
           <a:p>
             <a:pPr algn="ctr">
-              <a:defRPr sz="1600" b="1">
+              <a:defRPr sz="1400" b="1">
                 <a:solidFill>
                   <a:srgbClr val="FFFFFF"/>
                 </a:solidFill>
               </a:defRPr>
             </a:pPr>
             <a:r>
-              <a:t>VALIDATE</a:t>
+              <a:t>2. Preparar</a:t>
+            </a:r>
+            <a:br/>
+            <a:r>
+              <a:t>repositorios</a:t>
             </a:r>
             <a:br/>
             <a:br/>
             <a:r>
-              <a:t>¿Funcionaría la migración</a:t>
-            </a:r>
-            <a:br/>
-            <a:r>
-              <a:t>ahora mismo?</a:t>
-            </a:r>
-          </a:p>
-        </p:txBody>
-      </p:sp>
-      <p:sp>
-        <p:nvSpPr>
-          <p:cNvPr id="6" name="Rounded Rectangle 5"/>
+              <a:t>(cambio real)</a:t>
+            </a:r>
+          </a:p>
+        </p:txBody>
+      </p:sp>
+      <p:sp>
+        <p:nvSpPr>
+          <p:cNvPr id="7" name="Right Arrow 6"/>
           <p:cNvSpPr/>
           <p:nvPr/>
         </p:nvSpPr>
         <p:spPr>
           <a:xfrm>
-            <a:off x="8321040" y="1463040"/>
-            <a:ext cx="3520440" cy="1234440"/>
+            <a:off x="6217920" y="1901952"/>
+            <a:ext cx="320040" cy="219456"/>
+          </a:xfrm>
+          <a:prstGeom prst="rightArrow">
+            <a:avLst/>
+          </a:prstGeom>
+          <a:solidFill>
+            <a:srgbClr val="666666"/>
+          </a:solidFill>
+          <a:ln>
+            <a:noFill/>
+          </a:ln>
+        </p:spPr>
+        <p:style>
+          <a:lnRef idx="1">
+            <a:schemeClr val="accent1"/>
+          </a:lnRef>
+          <a:fillRef idx="3">
+            <a:schemeClr val="accent1"/>
+          </a:fillRef>
+          <a:effectRef idx="2">
+            <a:schemeClr val="accent1"/>
+          </a:effectRef>
+          <a:fontRef idx="minor">
+            <a:schemeClr val="lt1"/>
+          </a:fontRef>
+        </p:style>
+        <p:txBody>
+          <a:bodyPr rtlCol="0" anchor="ctr"/>
+          <a:lstStyle/>
+          <a:p>
+            <a:pPr algn="ctr"/>
+          </a:p>
+        </p:txBody>
+      </p:sp>
+      <p:sp>
+        <p:nvSpPr>
+          <p:cNvPr id="8" name="Rounded Rectangle 7"/>
+          <p:cNvSpPr/>
+          <p:nvPr/>
+        </p:nvSpPr>
+        <p:spPr>
+          <a:xfrm>
+            <a:off x="6217920" y="1508760"/>
+            <a:ext cx="2514600" cy="1005840"/>
           </a:xfrm>
           <a:prstGeom prst="roundRect">
             <a:avLst/>
@@ -7098,36 +7494,177 @@
           <a:lstStyle/>
           <a:p>
             <a:pPr algn="ctr">
-              <a:defRPr sz="1600" b="1">
+              <a:defRPr sz="1400" b="1">
                 <a:solidFill>
                   <a:srgbClr val="FFFFFF"/>
                 </a:solidFill>
               </a:defRPr>
             </a:pPr>
             <a:r>
-              <a:t>UPGRADE</a:t>
+              <a:t>3. Aplicar</a:t>
+            </a:r>
+            <a:br/>
+            <a:r>
+              <a:t>el upgrade</a:t>
             </a:r>
             <a:br/>
             <a:br/>
             <a:r>
-              <a:t>Ejecución real,</a:t>
+              <a:t>(cambio real,</a:t>
             </a:r>
             <a:br/>
             <a:r>
-              <a:t>con cambios</a:t>
-            </a:r>
-          </a:p>
-        </p:txBody>
-      </p:sp>
-      <p:sp>
-        <p:nvSpPr>
-          <p:cNvPr id="7" name="TextBox 6"/>
+              <a:t>reinicio)</a:t>
+            </a:r>
+          </a:p>
+        </p:txBody>
+      </p:sp>
+      <p:sp>
+        <p:nvSpPr>
+          <p:cNvPr id="9" name="Right Arrow 8"/>
+          <p:cNvSpPr/>
+          <p:nvPr/>
+        </p:nvSpPr>
+        <p:spPr>
+          <a:xfrm>
+            <a:off x="9052560" y="1901952"/>
+            <a:ext cx="320040" cy="219456"/>
+          </a:xfrm>
+          <a:prstGeom prst="rightArrow">
+            <a:avLst/>
+          </a:prstGeom>
+          <a:solidFill>
+            <a:srgbClr val="666666"/>
+          </a:solidFill>
+          <a:ln>
+            <a:noFill/>
+          </a:ln>
+        </p:spPr>
+        <p:style>
+          <a:lnRef idx="1">
+            <a:schemeClr val="accent1"/>
+          </a:lnRef>
+          <a:fillRef idx="3">
+            <a:schemeClr val="accent1"/>
+          </a:fillRef>
+          <a:effectRef idx="2">
+            <a:schemeClr val="accent1"/>
+          </a:effectRef>
+          <a:fontRef idx="minor">
+            <a:schemeClr val="lt1"/>
+          </a:fontRef>
+        </p:style>
+        <p:txBody>
+          <a:bodyPr rtlCol="0" anchor="ctr"/>
+          <a:lstStyle/>
+          <a:p>
+            <a:pPr algn="ctr"/>
+          </a:p>
+        </p:txBody>
+      </p:sp>
+      <p:sp>
+        <p:nvSpPr>
+          <p:cNvPr id="10" name="Rounded Rectangle 9"/>
+          <p:cNvSpPr/>
+          <p:nvPr/>
+        </p:nvSpPr>
+        <p:spPr>
+          <a:xfrm>
+            <a:off x="9052560" y="1508760"/>
+            <a:ext cx="2514600" cy="1005840"/>
+          </a:xfrm>
+          <a:prstGeom prst="roundRect">
+            <a:avLst/>
+          </a:prstGeom>
+          <a:solidFill>
+            <a:srgbClr val="666666"/>
+          </a:solidFill>
+          <a:ln>
+            <a:solidFill>
+              <a:srgbClr val="666666"/>
+            </a:solidFill>
+          </a:ln>
+          <a:effectLst/>
+        </p:spPr>
+        <p:style>
+          <a:lnRef idx="1">
+            <a:schemeClr val="accent1"/>
+          </a:lnRef>
+          <a:fillRef idx="3">
+            <a:schemeClr val="accent1"/>
+          </a:fillRef>
+          <a:effectRef idx="2">
+            <a:schemeClr val="accent1"/>
+          </a:effectRef>
+          <a:fontRef idx="minor">
+            <a:schemeClr val="lt1"/>
+          </a:fontRef>
+        </p:style>
+        <p:txBody>
+          <a:bodyPr rtlCol="0" anchor="ctr" wrap="square"/>
+          <a:lstStyle/>
+          <a:p>
+            <a:pPr algn="ctr">
+              <a:defRPr sz="1400" b="1">
+                <a:solidFill>
+                  <a:srgbClr val="FFFFFF"/>
+                </a:solidFill>
+              </a:defRPr>
+            </a:pPr>
+            <a:r>
+              <a:t>4. Reporte</a:t>
+            </a:r>
+            <a:br/>
+            <a:r>
+              <a:t>consolidado</a:t>
+            </a:r>
+          </a:p>
+        </p:txBody>
+      </p:sp>
+      <p:sp>
+        <p:nvSpPr>
+          <p:cNvPr id="11" name="TextBox 10"/>
           <p:cNvSpPr txBox="1"/>
           <p:nvPr/>
         </p:nvSpPr>
         <p:spPr>
           <a:xfrm>
-            <a:off x="640080" y="3108960"/>
+            <a:off x="5916168" y="2560320"/>
+            <a:ext cx="2834640" cy="365760"/>
+          </a:xfrm>
+          <a:prstGeom prst="rect">
+            <a:avLst/>
+          </a:prstGeom>
+          <a:noFill/>
+        </p:spPr>
+        <p:txBody>
+          <a:bodyPr wrap="none">
+            <a:spAutoFit/>
+          </a:bodyPr>
+          <a:lstStyle/>
+          <a:p>
+            <a:pPr algn="ctr">
+              <a:defRPr sz="1100" i="1">
+                <a:solidFill>
+                  <a:srgbClr val="B8860B"/>
+                </a:solidFill>
+              </a:defRPr>
+            </a:pPr>
+            <a:r>
+              <a:t>⬆ punto de aprobación opcional</a:t>
+            </a:r>
+          </a:p>
+        </p:txBody>
+      </p:sp>
+      <p:sp>
+        <p:nvSpPr>
+          <p:cNvPr id="12" name="TextBox 11"/>
+          <p:cNvSpPr txBox="1"/>
+          <p:nvPr/>
+        </p:nvSpPr>
+        <p:spPr>
+          <a:xfrm>
+            <a:off x="640080" y="2834640"/>
             <a:ext cx="10911535" cy="4846320"/>
           </a:xfrm>
           <a:prstGeom prst="rect">
@@ -7145,14 +7682,14 @@
               <a:spcAft>
                 <a:spcPts val="1000"/>
               </a:spcAft>
-              <a:defRPr sz="1600">
+              <a:defRPr sz="1400">
                 <a:solidFill>
                   <a:srgbClr val="333333"/>
                 </a:solidFill>
               </a:defRPr>
             </a:pPr>
             <a:r>
-              <a:t>•  PRECHECK nunca modifica nada: revisa salud del servidor y su preparación.</a:t>
+              <a:t>•  Por qué separar “preparar” de “aplicar”: permite que una persona (ej. un supervisor de cambios) autorice el paso irreversible (el reinicio) después de ver que la preparación salió bien, sin tener que repetir todo desde cero.</a:t>
             </a:r>
           </a:p>
           <a:p>
@@ -7160,14 +7697,14 @@
               <a:spcAft>
                 <a:spcPts val="1000"/>
               </a:spcAft>
-              <a:defRPr sz="1600">
+              <a:defRPr sz="1400">
                 <a:solidFill>
                   <a:srgbClr val="333333"/>
                 </a:solidFill>
               </a:defRPr>
             </a:pPr>
             <a:r>
-              <a:t>•  VALIDATE hace un ensayo real contra los repositorios Foreman, sin dejar ningún cambio permanente en el servidor.</a:t>
+              <a:t>•  Qué hace “preparar”: deja el servidor listo para migrar — respalda, deshabilita lo anterior, actualiza la herramienta de paquetes con los repositorios de origen, y agrega los repositorios de destino. Todavía NO aplica el cambio de Service Pack ni reinicia.</a:t>
             </a:r>
           </a:p>
           <a:p>
@@ -7175,14 +7712,14 @@
               <a:spcAft>
                 <a:spcPts val="1000"/>
               </a:spcAft>
-              <a:defRPr sz="1600">
+              <a:defRPr sz="1400">
                 <a:solidFill>
                   <a:srgbClr val="333333"/>
                 </a:solidFill>
               </a:defRPr>
             </a:pPr>
             <a:r>
-              <a:t>•  Solo UPGRADE modifica el servidor, y únicamente tras una confirmación explícita adicional.</a:t>
+              <a:t>•  Qué hace “aplicar”: primero repite, con el sistema real ya preparado, la misma simulación que recomienda SUSE antes de migrar (ver nota abajo); si todo está bien, aplica el cambio real y reinicia.</a:t>
             </a:r>
           </a:p>
           <a:p>
@@ -7190,21 +7727,75 @@
               <a:spcAft>
                 <a:spcPts val="1000"/>
               </a:spcAft>
-              <a:defRPr sz="1600">
+              <a:defRPr sz="1400">
                 <a:solidFill>
                   <a:srgbClr val="333333"/>
                 </a:solidFill>
               </a:defRPr>
             </a:pPr>
             <a:r>
-              <a:t>•  Estos tres niveles no son intercambiables: nunca se presenta un ensayo como si fuera la ejecución real, ni al revés.</a:t>
-            </a:r>
-          </a:p>
-        </p:txBody>
-      </p:sp>
-      <p:sp>
-        <p:nvSpPr>
-          <p:cNvPr id="8" name="TextBox 7"/>
+              <a:t>•  Es opcional: por defecto las 2 etapas se ejecutan juntas, en una sola corrida, exactamente igual que antes de incluir esta opción.</a:t>
+            </a:r>
+          </a:p>
+        </p:txBody>
+      </p:sp>
+      <p:sp>
+        <p:nvSpPr>
+          <p:cNvPr id="13" name="Rounded Rectangle 12"/>
+          <p:cNvSpPr/>
+          <p:nvPr/>
+        </p:nvSpPr>
+        <p:spPr>
+          <a:xfrm>
+            <a:off x="548640" y="5623560"/>
+            <a:ext cx="11094415" cy="868680"/>
+          </a:xfrm>
+          <a:prstGeom prst="roundRect">
+            <a:avLst/>
+          </a:prstGeom>
+          <a:solidFill>
+            <a:srgbClr val="F4F6F8"/>
+          </a:solidFill>
+          <a:ln>
+            <a:solidFill>
+              <a:srgbClr val="666666"/>
+            </a:solidFill>
+          </a:ln>
+        </p:spPr>
+        <p:style>
+          <a:lnRef idx="1">
+            <a:schemeClr val="accent1"/>
+          </a:lnRef>
+          <a:fillRef idx="3">
+            <a:schemeClr val="accent1"/>
+          </a:fillRef>
+          <a:effectRef idx="2">
+            <a:schemeClr val="accent1"/>
+          </a:effectRef>
+          <a:fontRef idx="minor">
+            <a:schemeClr val="lt1"/>
+          </a:fontRef>
+        </p:style>
+        <p:txBody>
+          <a:bodyPr rtlCol="0" anchor="ctr" wrap="square"/>
+          <a:lstStyle/>
+          <a:p>
+            <a:pPr algn="ctr">
+              <a:defRPr sz="1250">
+                <a:solidFill>
+                  <a:srgbClr val="333333"/>
+                </a:solidFill>
+              </a:defRPr>
+            </a:pPr>
+            <a:r>
+              <a:t>Por qué se hizo así: la guía oficial de SUSE (“SLES Upgrade Guide”, sección “Upgrading with plain Zypper”) ya indica ejecutar una simulación (zypper dup -D) y corregir cualquier problema ANTES de aplicar el cambio real (zypper dup). Separar “preparar” de “aplicar” simplemente hace visible, como un paso propio del flujo de aprobación, algo que el procedimiento oficial ya recomienda hacer antes de comprometerse al cambio real.</a:t>
+            </a:r>
+          </a:p>
+        </p:txBody>
+      </p:sp>
+      <p:sp>
+        <p:nvSpPr>
+          <p:cNvPr id="14" name="TextBox 13"/>
           <p:cNvSpPr txBox="1"/>
           <p:nvPr/>
         </p:nvSpPr>
@@ -7336,20 +7927,208 @@
               </a:defRPr>
             </a:pPr>
             <a:r>
-              <a:t>Repositorios internos Foreman/Katello</a:t>
-            </a:r>
-          </a:p>
-        </p:txBody>
-      </p:sp>
-      <p:sp>
-        <p:nvSpPr>
-          <p:cNvPr id="4" name="TextBox 3"/>
+              <a:t>Tres niveles, nunca confundidos</a:t>
+            </a:r>
+          </a:p>
+        </p:txBody>
+      </p:sp>
+      <p:sp>
+        <p:nvSpPr>
+          <p:cNvPr id="4" name="Rounded Rectangle 3"/>
+          <p:cNvSpPr/>
+          <p:nvPr/>
+        </p:nvSpPr>
+        <p:spPr>
+          <a:xfrm>
+            <a:off x="640080" y="1463040"/>
+            <a:ext cx="3520440" cy="1234440"/>
+          </a:xfrm>
+          <a:prstGeom prst="roundRect">
+            <a:avLst/>
+          </a:prstGeom>
+          <a:solidFill>
+            <a:srgbClr val="666666"/>
+          </a:solidFill>
+          <a:ln>
+            <a:solidFill>
+              <a:srgbClr val="666666"/>
+            </a:solidFill>
+          </a:ln>
+          <a:effectLst/>
+        </p:spPr>
+        <p:style>
+          <a:lnRef idx="1">
+            <a:schemeClr val="accent1"/>
+          </a:lnRef>
+          <a:fillRef idx="3">
+            <a:schemeClr val="accent1"/>
+          </a:fillRef>
+          <a:effectRef idx="2">
+            <a:schemeClr val="accent1"/>
+          </a:effectRef>
+          <a:fontRef idx="minor">
+            <a:schemeClr val="lt1"/>
+          </a:fontRef>
+        </p:style>
+        <p:txBody>
+          <a:bodyPr rtlCol="0" anchor="ctr" wrap="square"/>
+          <a:lstStyle/>
+          <a:p>
+            <a:pPr algn="ctr">
+              <a:defRPr sz="1600" b="1">
+                <a:solidFill>
+                  <a:srgbClr val="FFFFFF"/>
+                </a:solidFill>
+              </a:defRPr>
+            </a:pPr>
+            <a:r>
+              <a:t>PRECHECK</a:t>
+            </a:r>
+            <a:br/>
+            <a:br/>
+            <a:r>
+              <a:t>¿Está el servidor listo?</a:t>
+            </a:r>
+          </a:p>
+        </p:txBody>
+      </p:sp>
+      <p:sp>
+        <p:nvSpPr>
+          <p:cNvPr id="5" name="Rounded Rectangle 4"/>
+          <p:cNvSpPr/>
+          <p:nvPr/>
+        </p:nvSpPr>
+        <p:spPr>
+          <a:xfrm>
+            <a:off x="4480560" y="1463040"/>
+            <a:ext cx="3520440" cy="1234440"/>
+          </a:xfrm>
+          <a:prstGeom prst="roundRect">
+            <a:avLst/>
+          </a:prstGeom>
+          <a:solidFill>
+            <a:srgbClr val="1F7A6C"/>
+          </a:solidFill>
+          <a:ln>
+            <a:solidFill>
+              <a:srgbClr val="1F7A6C"/>
+            </a:solidFill>
+          </a:ln>
+          <a:effectLst/>
+        </p:spPr>
+        <p:style>
+          <a:lnRef idx="1">
+            <a:schemeClr val="accent1"/>
+          </a:lnRef>
+          <a:fillRef idx="3">
+            <a:schemeClr val="accent1"/>
+          </a:fillRef>
+          <a:effectRef idx="2">
+            <a:schemeClr val="accent1"/>
+          </a:effectRef>
+          <a:fontRef idx="minor">
+            <a:schemeClr val="lt1"/>
+          </a:fontRef>
+        </p:style>
+        <p:txBody>
+          <a:bodyPr rtlCol="0" anchor="ctr" wrap="square"/>
+          <a:lstStyle/>
+          <a:p>
+            <a:pPr algn="ctr">
+              <a:defRPr sz="1600" b="1">
+                <a:solidFill>
+                  <a:srgbClr val="FFFFFF"/>
+                </a:solidFill>
+              </a:defRPr>
+            </a:pPr>
+            <a:r>
+              <a:t>VALIDATE</a:t>
+            </a:r>
+            <a:br/>
+            <a:br/>
+            <a:r>
+              <a:t>¿Funcionaría la migración</a:t>
+            </a:r>
+            <a:br/>
+            <a:r>
+              <a:t>ahora mismo?</a:t>
+            </a:r>
+          </a:p>
+        </p:txBody>
+      </p:sp>
+      <p:sp>
+        <p:nvSpPr>
+          <p:cNvPr id="6" name="Rounded Rectangle 5"/>
+          <p:cNvSpPr/>
+          <p:nvPr/>
+        </p:nvSpPr>
+        <p:spPr>
+          <a:xfrm>
+            <a:off x="8321040" y="1463040"/>
+            <a:ext cx="3520440" cy="1234440"/>
+          </a:xfrm>
+          <a:prstGeom prst="roundRect">
+            <a:avLst/>
+          </a:prstGeom>
+          <a:solidFill>
+            <a:srgbClr val="1B2A4A"/>
+          </a:solidFill>
+          <a:ln>
+            <a:solidFill>
+              <a:srgbClr val="1B2A4A"/>
+            </a:solidFill>
+          </a:ln>
+          <a:effectLst/>
+        </p:spPr>
+        <p:style>
+          <a:lnRef idx="1">
+            <a:schemeClr val="accent1"/>
+          </a:lnRef>
+          <a:fillRef idx="3">
+            <a:schemeClr val="accent1"/>
+          </a:fillRef>
+          <a:effectRef idx="2">
+            <a:schemeClr val="accent1"/>
+          </a:effectRef>
+          <a:fontRef idx="minor">
+            <a:schemeClr val="lt1"/>
+          </a:fontRef>
+        </p:style>
+        <p:txBody>
+          <a:bodyPr rtlCol="0" anchor="ctr" wrap="square"/>
+          <a:lstStyle/>
+          <a:p>
+            <a:pPr algn="ctr">
+              <a:defRPr sz="1600" b="1">
+                <a:solidFill>
+                  <a:srgbClr val="FFFFFF"/>
+                </a:solidFill>
+              </a:defRPr>
+            </a:pPr>
+            <a:r>
+              <a:t>UPGRADE</a:t>
+            </a:r>
+            <a:br/>
+            <a:br/>
+            <a:r>
+              <a:t>Ejecución real,</a:t>
+            </a:r>
+            <a:br/>
+            <a:r>
+              <a:t>con cambios</a:t>
+            </a:r>
+          </a:p>
+        </p:txBody>
+      </p:sp>
+      <p:sp>
+        <p:nvSpPr>
+          <p:cNvPr id="7" name="TextBox 6"/>
           <p:cNvSpPr txBox="1"/>
           <p:nvPr/>
         </p:nvSpPr>
         <p:spPr>
           <a:xfrm>
-            <a:off x="640080" y="1371600"/>
+            <a:off x="640080" y="3108960"/>
             <a:ext cx="10911535" cy="4846320"/>
           </a:xfrm>
           <a:prstGeom prst="rect">
@@ -7367,14 +8146,14 @@
               <a:spcAft>
                 <a:spcPts val="1000"/>
               </a:spcAft>
-              <a:defRPr sz="1500">
+              <a:defRPr sz="1600">
                 <a:solidFill>
                   <a:srgbClr val="333333"/>
                 </a:solidFill>
               </a:defRPr>
             </a:pPr>
             <a:r>
-              <a:t>•  El upgrade usa exclusivamente los repositorios internos que el administrador configura en Foreman/Katello.</a:t>
+              <a:t>•  PRECHECK nunca modifica nada: revisa salud del servidor y su preparación.</a:t>
             </a:r>
           </a:p>
           <a:p>
@@ -7382,14 +8161,14 @@
               <a:spcAft>
                 <a:spcPts val="1000"/>
               </a:spcAft>
-              <a:defRPr sz="1500">
+              <a:defRPr sz="1600">
                 <a:solidFill>
                   <a:srgbClr val="333333"/>
                 </a:solidFill>
               </a:defRPr>
             </a:pPr>
             <a:r>
-              <a:t>•  No se usan repositorios públicos de SUSE en ningún momento de la migración.</a:t>
+              <a:t>•  VALIDATE hace un ensayo real contra los repositorios Foreman, sin dejar ningún cambio permanente en el servidor.</a:t>
             </a:r>
           </a:p>
           <a:p>
@@ -7397,14 +8176,14 @@
               <a:spcAft>
                 <a:spcPts val="1000"/>
               </a:spcAft>
-              <a:defRPr sz="1500">
+              <a:defRPr sz="1600">
                 <a:solidFill>
                   <a:srgbClr val="333333"/>
                 </a:solidFill>
               </a:defRPr>
             </a:pPr>
             <a:r>
-              <a:t>•  El estado de registro de SUSEConnect (registrado, mal registrado o no registrado) no determina ni bloquea el procedimiento; si se consulta, es solo informativo.</a:t>
+              <a:t>•  Solo UPGRADE modifica el servidor, y únicamente tras una confirmación explícita adicional.</a:t>
             </a:r>
           </a:p>
           <a:p>
@@ -7412,51 +8191,21 @@
               <a:spcAft>
                 <a:spcPts val="1000"/>
               </a:spcAft>
-              <a:defRPr sz="1500">
+              <a:defRPr sz="1600">
                 <a:solidFill>
                   <a:srgbClr val="333333"/>
                 </a:solidFill>
               </a:defRPr>
             </a:pPr>
             <a:r>
-              <a:t>•  Antes de migrar, se inventarían los repositorios ya existentes en el servidor y se deshabilitan los que estén activos — nunca se borran, y no se reactivan automáticamente al terminar.</a:t>
-            </a:r>
-          </a:p>
-          <a:p>
-            <a:pPr>
-              <a:spcAft>
-                <a:spcPts val="1000"/>
-              </a:spcAft>
-              <a:defRPr sz="1500">
-                <a:solidFill>
-                  <a:srgbClr val="333333"/>
-                </a:solidFill>
-              </a:defRPr>
-            </a:pPr>
-            <a:r>
-              <a:t>•  Los repositorios que la automatización agrega son temporales y quedan claramente identificados; al finalizar una etapa con éxito, se retiran automáticamente.</a:t>
-            </a:r>
-          </a:p>
-          <a:p>
-            <a:pPr>
-              <a:spcAft>
-                <a:spcPts val="1000"/>
-              </a:spcAft>
-              <a:defRPr sz="1500">
-                <a:solidFill>
-                  <a:srgbClr val="333333"/>
-                </a:solidFill>
-              </a:defRPr>
-            </a:pPr>
-            <a:r>
-              <a:t>•  El proceso corporativo de parchado, que administra los repositorios habituales de forma independiente, decide después qué hacer con lo que quedó deshabilitado.</a:t>
-            </a:r>
-          </a:p>
-        </p:txBody>
-      </p:sp>
-      <p:sp>
-        <p:nvSpPr>
-          <p:cNvPr id="5" name="TextBox 4"/>
+              <a:t>•  Estos tres niveles no son intercambiables: nunca se presenta un ensayo como si fuera la ejecución real, ni al revés.</a:t>
+            </a:r>
+          </a:p>
+        </p:txBody>
+      </p:sp>
+      <p:sp>
+        <p:nvSpPr>
+          <p:cNvPr id="8" name="TextBox 7"/>
           <p:cNvSpPr txBox="1"/>
           <p:nvPr/>
         </p:nvSpPr>
@@ -7498,6 +8247,258 @@
 </file>
 
 <file path=ppt/slides/slide8.xml><?xml version="1.0" encoding="utf-8"?>
+<p:sld xmlns:a="http://schemas.openxmlformats.org/drawingml/2006/main" xmlns:p="http://schemas.openxmlformats.org/presentationml/2006/main" xmlns:r="http://schemas.openxmlformats.org/officeDocument/2006/relationships">
+  <p:cSld>
+    <p:bg>
+      <p:bgPr>
+        <a:solidFill>
+          <a:srgbClr val="FFFFFF"/>
+        </a:solidFill>
+        <a:effectLst/>
+      </p:bgPr>
+    </p:bg>
+    <p:spTree>
+      <p:nvGrpSpPr>
+        <p:cNvPr id="1" name=""/>
+        <p:cNvGrpSpPr/>
+        <p:nvPr/>
+      </p:nvGrpSpPr>
+      <p:grpSpPr/>
+      <p:sp>
+        <p:nvSpPr>
+          <p:cNvPr id="2" name="Rectangle 1"/>
+          <p:cNvSpPr/>
+          <p:nvPr/>
+        </p:nvSpPr>
+        <p:spPr>
+          <a:xfrm>
+            <a:off x="0" y="0"/>
+            <a:ext cx="12191695" cy="1051560"/>
+          </a:xfrm>
+          <a:prstGeom prst="rect">
+            <a:avLst/>
+          </a:prstGeom>
+          <a:solidFill>
+            <a:srgbClr val="1B2A4A"/>
+          </a:solidFill>
+          <a:ln>
+            <a:noFill/>
+          </a:ln>
+        </p:spPr>
+        <p:style>
+          <a:lnRef idx="1">
+            <a:schemeClr val="accent1"/>
+          </a:lnRef>
+          <a:fillRef idx="3">
+            <a:schemeClr val="accent1"/>
+          </a:fillRef>
+          <a:effectRef idx="2">
+            <a:schemeClr val="accent1"/>
+          </a:effectRef>
+          <a:fontRef idx="minor">
+            <a:schemeClr val="lt1"/>
+          </a:fontRef>
+        </p:style>
+        <p:txBody>
+          <a:bodyPr rtlCol="0" anchor="ctr"/>
+          <a:lstStyle/>
+          <a:p>
+            <a:pPr algn="ctr"/>
+          </a:p>
+        </p:txBody>
+      </p:sp>
+      <p:sp>
+        <p:nvSpPr>
+          <p:cNvPr id="3" name="TextBox 2"/>
+          <p:cNvSpPr txBox="1"/>
+          <p:nvPr/>
+        </p:nvSpPr>
+        <p:spPr>
+          <a:xfrm>
+            <a:off x="548640" y="137160"/>
+            <a:ext cx="11094415" cy="640080"/>
+          </a:xfrm>
+          <a:prstGeom prst="rect">
+            <a:avLst/>
+          </a:prstGeom>
+          <a:noFill/>
+        </p:spPr>
+        <p:txBody>
+          <a:bodyPr wrap="square">
+            <a:spAutoFit/>
+          </a:bodyPr>
+          <a:lstStyle/>
+          <a:p>
+            <a:pPr>
+              <a:defRPr sz="2800" b="1">
+                <a:solidFill>
+                  <a:srgbClr val="FFFFFF"/>
+                </a:solidFill>
+              </a:defRPr>
+            </a:pPr>
+            <a:r>
+              <a:t>Repositorios internos Foreman/Katello</a:t>
+            </a:r>
+          </a:p>
+        </p:txBody>
+      </p:sp>
+      <p:sp>
+        <p:nvSpPr>
+          <p:cNvPr id="4" name="TextBox 3"/>
+          <p:cNvSpPr txBox="1"/>
+          <p:nvPr/>
+        </p:nvSpPr>
+        <p:spPr>
+          <a:xfrm>
+            <a:off x="640080" y="1371600"/>
+            <a:ext cx="10911535" cy="4846320"/>
+          </a:xfrm>
+          <a:prstGeom prst="rect">
+            <a:avLst/>
+          </a:prstGeom>
+          <a:noFill/>
+        </p:spPr>
+        <p:txBody>
+          <a:bodyPr wrap="square">
+            <a:spAutoFit/>
+          </a:bodyPr>
+          <a:lstStyle/>
+          <a:p>
+            <a:pPr>
+              <a:spcAft>
+                <a:spcPts val="1000"/>
+              </a:spcAft>
+              <a:defRPr sz="1500">
+                <a:solidFill>
+                  <a:srgbClr val="333333"/>
+                </a:solidFill>
+              </a:defRPr>
+            </a:pPr>
+            <a:r>
+              <a:t>•  El upgrade usa exclusivamente los repositorios internos que el administrador configura en Foreman/Katello.</a:t>
+            </a:r>
+          </a:p>
+          <a:p>
+            <a:pPr>
+              <a:spcAft>
+                <a:spcPts val="1000"/>
+              </a:spcAft>
+              <a:defRPr sz="1500">
+                <a:solidFill>
+                  <a:srgbClr val="333333"/>
+                </a:solidFill>
+              </a:defRPr>
+            </a:pPr>
+            <a:r>
+              <a:t>•  No se usan repositorios públicos de SUSE en ningún momento de la migración.</a:t>
+            </a:r>
+          </a:p>
+          <a:p>
+            <a:pPr>
+              <a:spcAft>
+                <a:spcPts val="1000"/>
+              </a:spcAft>
+              <a:defRPr sz="1500">
+                <a:solidFill>
+                  <a:srgbClr val="333333"/>
+                </a:solidFill>
+              </a:defRPr>
+            </a:pPr>
+            <a:r>
+              <a:t>•  El estado de registro de SUSEConnect (registrado, mal registrado o no registrado) no determina ni bloquea el procedimiento; si se consulta, es solo informativo.</a:t>
+            </a:r>
+          </a:p>
+          <a:p>
+            <a:pPr>
+              <a:spcAft>
+                <a:spcPts val="1000"/>
+              </a:spcAft>
+              <a:defRPr sz="1500">
+                <a:solidFill>
+                  <a:srgbClr val="333333"/>
+                </a:solidFill>
+              </a:defRPr>
+            </a:pPr>
+            <a:r>
+              <a:t>•  Antes de migrar, se inventarían los repositorios ya existentes en el servidor y se deshabilitan los que estén activos — nunca se borran, y no se reactivan automáticamente al terminar.</a:t>
+            </a:r>
+          </a:p>
+          <a:p>
+            <a:pPr>
+              <a:spcAft>
+                <a:spcPts val="1000"/>
+              </a:spcAft>
+              <a:defRPr sz="1500">
+                <a:solidFill>
+                  <a:srgbClr val="333333"/>
+                </a:solidFill>
+              </a:defRPr>
+            </a:pPr>
+            <a:r>
+              <a:t>•  Los repositorios que la automatización agrega son temporales y quedan claramente identificados; al finalizar una etapa con éxito, se retiran automáticamente.</a:t>
+            </a:r>
+          </a:p>
+          <a:p>
+            <a:pPr>
+              <a:spcAft>
+                <a:spcPts val="1000"/>
+              </a:spcAft>
+              <a:defRPr sz="1500">
+                <a:solidFill>
+                  <a:srgbClr val="333333"/>
+                </a:solidFill>
+              </a:defRPr>
+            </a:pPr>
+            <a:r>
+              <a:t>•  El proceso corporativo de parchado, que administra los repositorios habituales de forma independiente, decide después qué hacer con lo que quedó deshabilitado.</a:t>
+            </a:r>
+          </a:p>
+        </p:txBody>
+      </p:sp>
+      <p:sp>
+        <p:nvSpPr>
+          <p:cNvPr id="5" name="TextBox 4"/>
+          <p:cNvSpPr txBox="1"/>
+          <p:nvPr/>
+        </p:nvSpPr>
+        <p:spPr>
+          <a:xfrm>
+            <a:off x="457200" y="6446520"/>
+            <a:ext cx="11277295" cy="320040"/>
+          </a:xfrm>
+          <a:prstGeom prst="rect">
+            <a:avLst/>
+          </a:prstGeom>
+          <a:noFill/>
+        </p:spPr>
+        <p:txBody>
+          <a:bodyPr wrap="none">
+            <a:spAutoFit/>
+          </a:bodyPr>
+          <a:lstStyle/>
+          <a:p>
+            <a:pPr>
+              <a:defRPr sz="1100">
+                <a:solidFill>
+                  <a:srgbClr val="666666"/>
+                </a:solidFill>
+              </a:defRPr>
+            </a:pPr>
+            <a:r>
+              <a:t>ansible-sles-upgrade · Presentación ejecutiva</a:t>
+            </a:r>
+          </a:p>
+        </p:txBody>
+      </p:sp>
+    </p:spTree>
+  </p:cSld>
+  <p:clrMapOvr>
+    <a:masterClrMapping/>
+  </p:clrMapOvr>
+</p:sld>
+</file>
+
+<file path=ppt/slides/slide9.xml><?xml version="1.0" encoding="utf-8"?>
 <p:sld xmlns:a="http://schemas.openxmlformats.org/drawingml/2006/main" xmlns:p="http://schemas.openxmlformats.org/presentationml/2006/main" xmlns:r="http://schemas.openxmlformats.org/officeDocument/2006/relationships">
   <p:cSld>
     <p:bg>
@@ -8432,273 +9433,6 @@
 </p:sld>
 </file>
 
-<file path=ppt/slides/slide9.xml><?xml version="1.0" encoding="utf-8"?>
-<p:sld xmlns:a="http://schemas.openxmlformats.org/drawingml/2006/main" xmlns:p="http://schemas.openxmlformats.org/presentationml/2006/main" xmlns:r="http://schemas.openxmlformats.org/officeDocument/2006/relationships">
-  <p:cSld>
-    <p:bg>
-      <p:bgPr>
-        <a:solidFill>
-          <a:srgbClr val="FFFFFF"/>
-        </a:solidFill>
-        <a:effectLst/>
-      </p:bgPr>
-    </p:bg>
-    <p:spTree>
-      <p:nvGrpSpPr>
-        <p:cNvPr id="1" name=""/>
-        <p:cNvGrpSpPr/>
-        <p:nvPr/>
-      </p:nvGrpSpPr>
-      <p:grpSpPr/>
-      <p:sp>
-        <p:nvSpPr>
-          <p:cNvPr id="2" name="Rectangle 1"/>
-          <p:cNvSpPr/>
-          <p:nvPr/>
-        </p:nvSpPr>
-        <p:spPr>
-          <a:xfrm>
-            <a:off x="0" y="0"/>
-            <a:ext cx="12191695" cy="1051560"/>
-          </a:xfrm>
-          <a:prstGeom prst="rect">
-            <a:avLst/>
-          </a:prstGeom>
-          <a:solidFill>
-            <a:srgbClr val="1B2A4A"/>
-          </a:solidFill>
-          <a:ln>
-            <a:noFill/>
-          </a:ln>
-        </p:spPr>
-        <p:style>
-          <a:lnRef idx="1">
-            <a:schemeClr val="accent1"/>
-          </a:lnRef>
-          <a:fillRef idx="3">
-            <a:schemeClr val="accent1"/>
-          </a:fillRef>
-          <a:effectRef idx="2">
-            <a:schemeClr val="accent1"/>
-          </a:effectRef>
-          <a:fontRef idx="minor">
-            <a:schemeClr val="lt1"/>
-          </a:fontRef>
-        </p:style>
-        <p:txBody>
-          <a:bodyPr rtlCol="0" anchor="ctr"/>
-          <a:lstStyle/>
-          <a:p>
-            <a:pPr algn="ctr"/>
-          </a:p>
-        </p:txBody>
-      </p:sp>
-      <p:sp>
-        <p:nvSpPr>
-          <p:cNvPr id="3" name="TextBox 2"/>
-          <p:cNvSpPr txBox="1"/>
-          <p:nvPr/>
-        </p:nvSpPr>
-        <p:spPr>
-          <a:xfrm>
-            <a:off x="548640" y="137160"/>
-            <a:ext cx="11094415" cy="640080"/>
-          </a:xfrm>
-          <a:prstGeom prst="rect">
-            <a:avLst/>
-          </a:prstGeom>
-          <a:noFill/>
-        </p:spPr>
-        <p:txBody>
-          <a:bodyPr wrap="square">
-            <a:spAutoFit/>
-          </a:bodyPr>
-          <a:lstStyle/>
-          <a:p>
-            <a:pPr>
-              <a:defRPr sz="2800" b="1">
-                <a:solidFill>
-                  <a:srgbClr val="FFFFFF"/>
-                </a:solidFill>
-              </a:defRPr>
-            </a:pPr>
-            <a:r>
-              <a:t>Controles y consideraciones para producción</a:t>
-            </a:r>
-          </a:p>
-        </p:txBody>
-      </p:sp>
-      <p:sp>
-        <p:nvSpPr>
-          <p:cNvPr id="4" name="TextBox 3"/>
-          <p:cNvSpPr txBox="1"/>
-          <p:nvPr/>
-        </p:nvSpPr>
-        <p:spPr>
-          <a:xfrm>
-            <a:off x="640080" y="1371600"/>
-            <a:ext cx="10911535" cy="4846320"/>
-          </a:xfrm>
-          <a:prstGeom prst="rect">
-            <a:avLst/>
-          </a:prstGeom>
-          <a:noFill/>
-        </p:spPr>
-        <p:txBody>
-          <a:bodyPr wrap="square">
-            <a:spAutoFit/>
-          </a:bodyPr>
-          <a:lstStyle/>
-          <a:p>
-            <a:pPr>
-              <a:spcAft>
-                <a:spcPts val="1000"/>
-              </a:spcAft>
-              <a:defRPr sz="1500">
-                <a:solidFill>
-                  <a:srgbClr val="333333"/>
-                </a:solidFill>
-              </a:defRPr>
-            </a:pPr>
-            <a:r>
-              <a:t>•  Un servidor a la vez por defecto (procesamiento serial), para minimizar el impacto de cualquier imprevisto.</a:t>
-            </a:r>
-          </a:p>
-          <a:p>
-            <a:pPr>
-              <a:spcAft>
-                <a:spcPts val="1000"/>
-              </a:spcAft>
-              <a:defRPr sz="1500">
-                <a:solidFill>
-                  <a:srgbClr val="333333"/>
-                </a:solidFill>
-              </a:defRPr>
-            </a:pPr>
-            <a:r>
-              <a:t>•  Ensayo real disponible (VALIDATE) antes de cualquier cambio, y una verificación interna obligatoria se repite automáticamente justo antes de aplicar cualquier cambio real.</a:t>
-            </a:r>
-          </a:p>
-          <a:p>
-            <a:pPr>
-              <a:spcAft>
-                <a:spcPts val="1000"/>
-              </a:spcAft>
-              <a:defRPr sz="1500">
-                <a:solidFill>
-                  <a:srgbClr val="333333"/>
-                </a:solidFill>
-              </a:defRPr>
-            </a:pPr>
-            <a:r>
-              <a:t>•  Una migración real requiere una confirmación explícita adicional, verificada antes de tocar cualquier repositorio; no puede ocurrir por accidente.</a:t>
-            </a:r>
-          </a:p>
-          <a:p>
-            <a:pPr>
-              <a:spcAft>
-                <a:spcPts val="1000"/>
-              </a:spcAft>
-              <a:defRPr sz="1500">
-                <a:solidFill>
-                  <a:srgbClr val="333333"/>
-                </a:solidFill>
-              </a:defRPr>
-            </a:pPr>
-            <a:r>
-              <a:t>•  El reinicio tras una migración real es siempre obligatorio: no existe una opción para omitirlo.</a:t>
-            </a:r>
-          </a:p>
-          <a:p>
-            <a:pPr>
-              <a:spcAft>
-                <a:spcPts val="1000"/>
-              </a:spcAft>
-              <a:defRPr sz="1500">
-                <a:solidFill>
-                  <a:srgbClr val="333333"/>
-                </a:solidFill>
-              </a:defRPr>
-            </a:pPr>
-            <a:r>
-              <a:t>•  SP6 debe quedar realmente validado (aplicado, reiniciado, sistema operativo, servicios y GeoPOS) antes de que el mismo servidor continúe hacia SP7.</a:t>
-            </a:r>
-          </a:p>
-          <a:p>
-            <a:pPr>
-              <a:spcAft>
-                <a:spcPts val="1000"/>
-              </a:spcAft>
-              <a:defRPr sz="1500">
-                <a:solidFill>
-                  <a:srgbClr val="333333"/>
-                </a:solidFill>
-              </a:defRPr>
-            </a:pPr>
-            <a:r>
-              <a:t>•  Ante cualquier fallo, la información de diagnóstico se conserva por defecto en el propio servidor (no se limpia a ciegas).</a:t>
-            </a:r>
-          </a:p>
-          <a:p>
-            <a:pPr>
-              <a:spcAft>
-                <a:spcPts val="1000"/>
-              </a:spcAft>
-              <a:defRPr sz="1500">
-                <a:solidFill>
-                  <a:srgbClr val="333333"/>
-                </a:solidFill>
-              </a:defRPr>
-            </a:pPr>
-            <a:r>
-              <a:t>•  Todo el alcance de servidores se controla desde AWX (“Limit”), evitando ejecuciones accidentales sobre servidores no previstos.</a:t>
-            </a:r>
-          </a:p>
-        </p:txBody>
-      </p:sp>
-      <p:sp>
-        <p:nvSpPr>
-          <p:cNvPr id="5" name="TextBox 4"/>
-          <p:cNvSpPr txBox="1"/>
-          <p:nvPr/>
-        </p:nvSpPr>
-        <p:spPr>
-          <a:xfrm>
-            <a:off x="457200" y="6446520"/>
-            <a:ext cx="11277295" cy="320040"/>
-          </a:xfrm>
-          <a:prstGeom prst="rect">
-            <a:avLst/>
-          </a:prstGeom>
-          <a:noFill/>
-        </p:spPr>
-        <p:txBody>
-          <a:bodyPr wrap="none">
-            <a:spAutoFit/>
-          </a:bodyPr>
-          <a:lstStyle/>
-          <a:p>
-            <a:pPr>
-              <a:defRPr sz="1100">
-                <a:solidFill>
-                  <a:srgbClr val="666666"/>
-                </a:solidFill>
-              </a:defRPr>
-            </a:pPr>
-            <a:r>
-              <a:t>ansible-sles-upgrade · Presentación ejecutiva</a:t>
-            </a:r>
-          </a:p>
-        </p:txBody>
-      </p:sp>
-    </p:spTree>
-  </p:cSld>
-  <p:clrMapOvr>
-    <a:masterClrMapping/>
-  </p:clrMapOvr>
-</p:sld>
-</file>
-
 <file path=ppt/theme/theme1.xml><?xml version="1.0" encoding="utf-8"?>
 <a:theme xmlns:a="http://schemas.openxmlformats.org/drawingml/2006/main" name="Office Theme">
   <a:themeElements>

</xml_diff>

<commit_message>
Actualización automática: 2026-10-05 17:33:41
</commit_message>
<xml_diff>
--- a/sles15-upgradeV1/docs/presentacion/ansible-sles-upgrade-presentacion-ejecutiva.pptx
+++ b/sles15-upgradeV1/docs/presentacion/ansible-sles-upgrade-presentacion-ejecutiva.pptx
@@ -7081,7 +7081,7 @@
               </a:defRPr>
             </a:pPr>
             <a:r>
-              <a:t>Los pasos 3 (preparar repos) y 4-6 (aplicar el cambio) pueden ejecutarse juntos (por defecto) o como 2 etapas separadas con aprobación entre ambas — ver diapositiva siguiente.</a:t>
+              <a:t>Por defecto, los pasos 3 (preparar repos) y 4-6 (aplicar el cambio) se ejecutan como 2 etapas separadas, con un punto de aprobación entre ambas — ver diapositiva siguiente.</a:t>
             </a:r>
           </a:p>
         </p:txBody>
@@ -7220,7 +7220,7 @@
               </a:defRPr>
             </a:pPr>
             <a:r>
-              <a:t>Opcional: separar “Preparar” de “Aplicar”</a:t>
+              <a:t>Configuración por defecto: “Preparar” y “Aplicar” separados</a:t>
             </a:r>
           </a:p>
           <a:p>
@@ -7651,7 +7651,7 @@
               </a:defRPr>
             </a:pPr>
             <a:r>
-              <a:t>⬆ punto de aprobación opcional</a:t>
+              <a:t>⬆ punto de aprobación (opcional insertar un Approval Node aquí)</a:t>
             </a:r>
           </a:p>
         </p:txBody>
@@ -7734,7 +7734,7 @@
               </a:defRPr>
             </a:pPr>
             <a:r>
-              <a:t>•  Es opcional: por defecto las 2 etapas se ejecutan juntas, en una sola corrida, exactamente igual que antes de incluir esta opción.</a:t>
+              <a:t>•  Es la configuración por defecto de este proyecto; existe una alternativa simplificada (las 2 etapas en una sola corrida) para casos donde no se necesita el punto de aprobación.</a:t>
             </a:r>
           </a:p>
         </p:txBody>

</xml_diff>

<commit_message>
Actualización automática: 2026-10-06 11:22:23
</commit_message>
<xml_diff>
--- a/sles15-upgradeV1/docs/presentacion/ansible-sles-upgrade-presentacion-ejecutiva.pptx
+++ b/sles15-upgradeV1/docs/presentacion/ansible-sles-upgrade-presentacion-ejecutiva.pptx
@@ -8153,7 +8153,7 @@
               </a:defRPr>
             </a:pPr>
             <a:r>
-              <a:t>•  PRECHECK nunca modifica nada: revisa salud del servidor y su preparación.</a:t>
+              <a:t>•  PRECHECK revisa salud del servidor y su preparación; no modifica repositorios ni paquetes (única excepción: puede instalar la CA interna si todavía no está presente, operación idempotente).</a:t>
             </a:r>
           </a:p>
           <a:p>
@@ -8168,7 +8168,7 @@
               </a:defRPr>
             </a:pPr>
             <a:r>
-              <a:t>•  VALIDATE hace un ensayo real contra los repositorios Foreman, sin dejar ningún cambio permanente en el servidor.</a:t>
+              <a:t>•  VALIDATE hace un ensayo real contra los repositorios Foreman, sin dejar ningún cambio permanente en el servidor (misma excepción de la CA interna).</a:t>
             </a:r>
           </a:p>
           <a:p>
@@ -8183,7 +8183,7 @@
               </a:defRPr>
             </a:pPr>
             <a:r>
-              <a:t>•  Solo UPGRADE modifica el servidor, y únicamente tras una confirmación explícita adicional.</a:t>
+              <a:t>•  Solo UPGRADE modifica repositorios y paquetes del servidor, y únicamente tras una confirmación explícita adicional.</a:t>
             </a:r>
           </a:p>
           <a:p>

</xml_diff>